<commit_message>
docs: refresh video deck with 64-test count and live-demo narration
</commit_message>
<xml_diff>
--- a/docs/Diapositivas_Video_SegundoCorte.pptx
+++ b/docs/Diapositivas_Video_SegundoCorte.pptx
@@ -120,18 +120,18 @@
   <p:extLst>
     <p:ext uri="{521415D9-36F7-43E2-AB2F-B90AF26B5E84}">
       <p14:sectionLst xmlns:p14="http://schemas.microsoft.com/office/powerpoint/2010/main">
-        <p14:section name="Apertura" id="{ebf1d8ff-7965-7c52-0be1-7fddd2d8a44a}">
+        <p14:section name="Apertura" id="{ff9af3a3-119a-047f-c92e-6b29b734e9b5}">
           <p14:sldIdLst>
             <p14:sldId id="256"/>
           </p14:sldIdLst>
         </p14:section>
-        <p14:section name="Arquitectura" id="{d475965f-41ed-5d92-d3a2-7b5175257b57}">
+        <p14:section name="Arquitectura" id="{a34c86af-43b2-6975-fcdd-c9080eb8dbef}">
           <p14:sldIdLst>
             <p14:sldId id="257"/>
             <p14:sldId id="258"/>
           </p14:sldIdLst>
         </p14:section>
-        <p14:section name="Implementación" id="{d1980fc9-6303-5f7a-5288-d266b0e2673d}">
+        <p14:section name="Implementación" id="{791ce639-5182-ea96-b5ac-62c3e28745a4}">
           <p14:sldIdLst>
             <p14:sldId id="259"/>
             <p14:sldId id="260"/>
@@ -139,20 +139,20 @@
             <p14:sldId id="262"/>
           </p14:sldIdLst>
         </p14:section>
-        <p14:section name="Validación" id="{a3076931-42bd-c58e-084d-77ae73f85af9}">
+        <p14:section name="Validación" id="{61c9f881-0ccd-503d-12de-b39067d4c726}">
           <p14:sldIdLst>
             <p14:sldId id="263"/>
             <p14:sldId id="264"/>
             <p14:sldId id="265"/>
           </p14:sldIdLst>
         </p14:section>
-        <p14:section name="Preguntas" id="{332513ec-a085-8c4f-a3b5-195409c8178d}">
+        <p14:section name="Preguntas" id="{fd60c503-d443-0b5e-1a05-e34f1ea41fb4}">
           <p14:sldIdLst>
             <p14:sldId id="266"/>
             <p14:sldId id="267"/>
           </p14:sldIdLst>
         </p14:section>
-        <p14:section name="Cierre" id="{02d786a8-6a34-3f04-9666-e3356ad0415d}">
+        <p14:section name="Cierre" id="{4cb7791a-28f3-9dd1-1539-ba9bb958c868}">
           <p14:sldIdLst>
             <p14:sldId id="268"/>
             <p14:sldId id="269"/>
@@ -1374,7 +1374,7 @@
             <a:r>
               <a:rPr lang="en-US" dirty="0"/>
               <a:t>[En pantalla: terminal con "python firmware/firmware_simulador.py" corriendo y las tramas JSON visibles]
-Acá tengo el firmware simulado corriendo de verdad, no una captura de pantalla. Es un servidor TCP que escucha en el puerto 8765 y, cada segundo, emite una trama JSON con el identificador del dispositivo, temperatura, humedad y vibración. Cada siete ciclos, inyecta deliberadamente una anomalía en una de las tres variables, para que la aplicación tenga algo real que clasificar como condición anómala. Todo esto corre con la librería estándar de Python, sin ninguna dependencia externa ni hardware.</a:t>
+Con un doble clic en DEMO.bat se levantan el firmware, la aplicación y este panel de monitoreo. Acá tengo el firmware simulado corriendo de verdad, no una captura de pantalla. Es un servidor TCP que escucha en el puerto 8765 y, cada segundo, emite una trama JSON con el identificador del dispositivo, temperatura, humedad y vibración. Cada siete ciclos, inyecta deliberadamente una anomalía en una de las tres variables, para que la aplicación tenga algo real que clasificar como condición anómala. Todo esto corre con la librería estándar de Python, sin ninguna dependencia externa ni hardware.</a:t>
             </a:r>
             <a:endParaRPr lang="en-US" dirty="0"/>
           </a:p>
@@ -1640,8 +1640,8 @@
           <a:p>
             <a:r>
               <a:rPr lang="en-US" dirty="0"/>
-              <a:t>[En pantalla: terminal ejecutando "pytest tests/ -v" en vivo, 28 en verde; luego docs/Matriz_Pruebas.md]
-El proyecto tiene veintiocho pruebas automáticas con pytest, escritas con test primero, implementación después — es decir, TDD real. Las voy a correr ahora mismo [ejecutar pytest tests/ -v en pantalla]. Como se ve, las veintiocho pasan. La matriz de pruebas del documento técnico cruza cada requisito funcional con su prueba automática y, cuando corresponde, con una corrida manual real contra el sistema completo — no son pruebas teóricas, son pruebas que de verdad se ejecutaron.</a:t>
+              <a:t>[En pantalla: terminal ejecutando "pytest tests/ -v" en vivo, 64 en verde; luego docs/Matriz_Pruebas.md]
+El proyecto tiene sesenta y cuatro pruebas automáticas con pytest, escritas con test primero, implementación después — es decir, TDD real. Las voy a correr ahora mismo [ejecutar pytest tests/ -v en pantalla]. Como se ve, las sesenta y cuatro pasan. La matriz de pruebas del documento técnico cruza cada requisito funcional con su prueba automática y, cuando corresponde, con una corrida manual real contra el sistema completo — no son pruebas teóricas, son pruebas que de verdad se ejecutaron.</a:t>
             </a:r>
             <a:endParaRPr lang="en-US" dirty="0"/>
           </a:p>
@@ -1730,7 +1730,7 @@
             <a:r>
               <a:rPr lang="en-US" dirty="0"/>
               <a:t>[En pantalla: logs/sistema.log y el fallo 6 de docs/Fallos_Controlados.md]
-Este es el log del sistema, con fecha, hora, nivel y evento de cada lectura procesada. Y esto es evidencia real de uno de los seis fallos controlados que exige la guía: maté el proceso del firmware a mitad de una corrida de cuarenta lecturas, y lo volví a levantar unos segundos después. Acá se ve el error real de Windows cuando se cae la conexión, los reintentos con espera creciente, y la línea donde la aplicación confirma que recuperó la conexión — tres coma cincuenta y siete segundos después — y sigue procesando sin que el proceso se haya caído en ningún momento. Los otros cinco fallos, con la misma evidencia real, están documentados en el repositorio.</a:t>
+Ahora lo más importante: qué pasa cuando algo falla. Desde este panel provoco fallos reales. Fuerzo una anomalía y aparece el punto rojo. Mando un dato corrupto y un valor fuera de rango: suben los contadores, y el sistema sigue leyendo. Ahora detengo el firmware: el estado pasa a reconectando y en el registro se ven los reintentos con espera creciente. Lo reinicio, y la aplicación se reconecta sola, sin reiniciarla. Por último saturo la CPU: la gráfica sube casi al cien por ciento y la integración sigue funcionando. Estos seis fallos, con su salida de consola real, están documentados en el repositorio.</a:t>
             </a:r>
             <a:endParaRPr lang="en-US" dirty="0"/>
           </a:p>
@@ -7517,7 +7517,7 @@
                   <a:schemeClr val="tx1"/>
                 </a:solidFill>
               </a:rPr>
-              <a:t>TDD: 28 pruebas escritas antes que el código</a:t>
+              <a:t>TDD: 64 pruebas escritas antes que el código</a:t>
             </a:r>
             <a:endParaRPr lang="en-US" sz="1400" dirty="0"/>
           </a:p>
@@ -8984,7 +8984,7 @@
                 <a:ea typeface="Courier New" pitchFamily="34" charset="-122"/>
                 <a:cs typeface="Courier New" pitchFamily="34" charset="-120"/>
               </a:rPr>
-              <a:t>28 pruebas pytest</a:t>
+              <a:t>64 pruebas pytest</a:t>
             </a:r>
             <a:endParaRPr lang="en-US" sz="1300" dirty="0"/>
           </a:p>
@@ -9205,7 +9205,7 @@
                   <a:schemeClr val="accent4"/>
                 </a:solidFill>
               </a:rPr>
-              <a:t>28</a:t>
+              <a:t>64</a:t>
             </a:r>
             <a:endParaRPr lang="en-US" sz="4400" dirty="0"/>
           </a:p>
@@ -14760,7 +14760,7 @@
                             <a:schemeClr val="tx1"/>
                           </a:solidFill>
                         </a:rPr>
-                        <a:t>3 pruebas + snapshot real en el reporte</a:t>
+                        <a:t>5 pruebas + snapshot real en el reporte</a:t>
                       </a:r>
                       <a:endParaRPr lang="en-US" sz="1200" dirty="0"/>
                     </a:p>
@@ -15685,7 +15685,7 @@
                   <a:schemeClr val="tx1"/>
                 </a:solidFill>
               </a:rPr>
-              <a:t>28 de 28 pruebas pytest en verde · detalle completo en docs/Matriz_Pruebas.md</a:t>
+              <a:t>64 de 64 pruebas pytest en verde · detalle completo en docs/Matriz_Pruebas.md</a:t>
             </a:r>
             <a:endParaRPr lang="en-US" sz="1400" dirty="0"/>
           </a:p>

</xml_diff>

<commit_message>
docs: document the public cloud deployment and polish the read-only notice
</commit_message>
<xml_diff>
--- a/docs/Diapositivas_Video_SegundoCorte.pptx
+++ b/docs/Diapositivas_Video_SegundoCorte.pptx
@@ -121,18 +121,18 @@
   <p:extLst>
     <p:ext uri="{521415D9-36F7-43E2-AB2F-B90AF26B5E84}">
       <p14:sectionLst xmlns:p14="http://schemas.microsoft.com/office/powerpoint/2010/main">
-        <p14:section name="Apertura" id="{2d305e10-dce3-4d33-15aa-0f3a0098d1b7}">
+        <p14:section name="Apertura" id="{398700cc-543b-675d-9584-f56ccbbd3c3f}">
           <p14:sldIdLst>
             <p14:sldId id="256"/>
           </p14:sldIdLst>
         </p14:section>
-        <p14:section name="Arquitectura" id="{6e91371b-01a4-951f-df69-d5e966b45735}">
+        <p14:section name="Arquitectura" id="{f245be49-95b0-9ce4-60c3-3ec96454dce4}">
           <p14:sldIdLst>
             <p14:sldId id="257"/>
             <p14:sldId id="258"/>
           </p14:sldIdLst>
         </p14:section>
-        <p14:section name="Implementación" id="{c9ed07e1-af28-4d54-c5f6-a5d161f7b1db}">
+        <p14:section name="Implementación" id="{646a633e-a628-d38e-bd02-72f8542d0178}">
           <p14:sldIdLst>
             <p14:sldId id="259"/>
             <p14:sldId id="260"/>
@@ -141,20 +141,20 @@
             <p14:sldId id="263"/>
           </p14:sldIdLst>
         </p14:section>
-        <p14:section name="Validación" id="{d46972bc-dd35-f88c-7136-be19b05c8746}">
+        <p14:section name="Validación" id="{a68b80f3-980d-f14d-86d9-ac4a1a176146}">
           <p14:sldIdLst>
             <p14:sldId id="264"/>
             <p14:sldId id="265"/>
             <p14:sldId id="266"/>
           </p14:sldIdLst>
         </p14:section>
-        <p14:section name="Preguntas" id="{748c4de0-9bd0-b201-cee7-4acc17af2580}">
+        <p14:section name="Preguntas" id="{397792e8-0835-a05a-f1bb-ac5a02457d27}">
           <p14:sldIdLst>
             <p14:sldId id="267"/>
             <p14:sldId id="268"/>
           </p14:sldIdLst>
         </p14:section>
-        <p14:section name="Cierre" id="{08e35ac9-2791-a53a-2d55-dc7ba1624019}">
+        <p14:section name="Cierre" id="{4bf8bd68-d0e3-2ad4-171e-c9a177f29d78}">
           <p14:sldIdLst>
             <p14:sldId id="269"/>
             <p14:sldId id="270"/>
@@ -1376,7 +1376,7 @@
             <a:r>
               <a:rPr lang="en-US" dirty="0"/>
               <a:t>[En pantalla: github.com/Facabore/practica-hsf-segundo-corte con el README renderizado]
-Este es el repositorio en GitHub. La estructura separa claramente la aplicación en hsf_app, el firmware simulado, las pruebas, los scripts de demo, los diagramas y la documentación. El README explica cómo instalar las dependencias y cómo correr el sistema completo, con dos terminales: una para el firmware y otra para la aplicación. Todo lo que voy a mostrar en este video se puede reproducir exactamente con estos comandos, en Windows o en Linux.</a:t>
+Este es el repositorio en GitHub. La estructura separa claramente la aplicación en hsf_app, el firmware simulado, las pruebas, los scripts de demo, los diagramas y la documentación. El README explica cómo instalar las dependencias y cómo correr el sistema completo, con dos terminales: una para el firmware y otra para la aplicación. Todo lo que voy a mostrar en este video se puede reproducir exactamente con estos comandos, en Windows o en Linux. Además, el sistema quedó publicado en la nube, con HTTPS, en integration-corte2.duckdns.org: cualquiera puede verlo funcionando en vivo, en modo solo lectura.</a:t>
             </a:r>
             <a:endParaRPr lang="en-US" dirty="0"/>
           </a:p>
@@ -7580,7 +7580,21 @@
                   <a:schemeClr val="tx1"/>
                 </a:solidFill>
               </a:rPr>
-              <a:t>Código, pruebas, evidencia y documento técnico: github.com/Facabore/practica-hsf-segundo-corte</a:t>
+              <a:t>Código y documento técnico: github.com/Facabore/practica-hsf-segundo-corte</a:t>
+            </a:r>
+            <a:endParaRPr lang="en-US" sz="1400" dirty="0"/>
+          </a:p>
+          <a:p>
+            <a:pPr indent="0" marL="0">
+              <a:buNone/>
+            </a:pPr>
+            <a:r>
+              <a:rPr lang="en-US" sz="1400" b="1" dirty="0">
+                <a:solidFill>
+                  <a:schemeClr val="tx1"/>
+                </a:solidFill>
+              </a:rPr>
+              <a:t>Demo en vivo en la nube: https://integration-corte2.duckdns.org</a:t>
             </a:r>
             <a:endParaRPr lang="en-US" sz="1400" dirty="0"/>
           </a:p>

</xml_diff>

<commit_message>
docs: describe on/off/restart controls and open cloud dashboard
</commit_message>
<xml_diff>
--- a/docs/Diapositivas_Video_SegundoCorte.pptx
+++ b/docs/Diapositivas_Video_SegundoCorte.pptx
@@ -121,18 +121,18 @@
   <p:extLst>
     <p:ext uri="{521415D9-36F7-43E2-AB2F-B90AF26B5E84}">
       <p14:sectionLst xmlns:p14="http://schemas.microsoft.com/office/powerpoint/2010/main">
-        <p14:section name="Apertura" id="{398700cc-543b-675d-9584-f56ccbbd3c3f}">
+        <p14:section name="Apertura" id="{b87cdde9-12ca-c175-ee9c-f57bf3cad8ea}">
           <p14:sldIdLst>
             <p14:sldId id="256"/>
           </p14:sldIdLst>
         </p14:section>
-        <p14:section name="Arquitectura" id="{f245be49-95b0-9ce4-60c3-3ec96454dce4}">
+        <p14:section name="Arquitectura" id="{a563c1c7-88cc-c8b4-794a-4cda50f3efcc}">
           <p14:sldIdLst>
             <p14:sldId id="257"/>
             <p14:sldId id="258"/>
           </p14:sldIdLst>
         </p14:section>
-        <p14:section name="Implementación" id="{646a633e-a628-d38e-bd02-72f8542d0178}">
+        <p14:section name="Implementación" id="{344e306b-6346-568a-c052-95355b15eaff}">
           <p14:sldIdLst>
             <p14:sldId id="259"/>
             <p14:sldId id="260"/>
@@ -141,20 +141,20 @@
             <p14:sldId id="263"/>
           </p14:sldIdLst>
         </p14:section>
-        <p14:section name="Validación" id="{a68b80f3-980d-f14d-86d9-ac4a1a176146}">
+        <p14:section name="Validación" id="{20da7408-9bb4-6ea5-b6f8-efd86be1bd8d}">
           <p14:sldIdLst>
             <p14:sldId id="264"/>
             <p14:sldId id="265"/>
             <p14:sldId id="266"/>
           </p14:sldIdLst>
         </p14:section>
-        <p14:section name="Preguntas" id="{397792e8-0835-a05a-f1bb-ac5a02457d27}">
+        <p14:section name="Preguntas" id="{fb5fb8f7-727d-c674-07d9-738f45259f0c}">
           <p14:sldIdLst>
             <p14:sldId id="267"/>
             <p14:sldId id="268"/>
           </p14:sldIdLst>
         </p14:section>
-        <p14:section name="Cierre" id="{4bf8bd68-d0e3-2ad4-171e-c9a177f29d78}">
+        <p14:section name="Cierre" id="{459247b3-ba87-39cd-bc4c-73513748137c}">
           <p14:sldIdLst>
             <p14:sldId id="269"/>
             <p14:sldId id="270"/>
@@ -654,7 +654,7 @@
             <a:r>
               <a:rPr lang="en-US" dirty="0"/>
               <a:t>[En pantalla: logs/sistema.log y el fallo 6 de docs/Fallos_Controlados.md]
-Ahora lo más importante: qué pasa cuando algo falla. Desde este panel provoco fallos reales. Fuerzo una anomalía y aparece el punto rojo. Mando un dato corrupto y un valor fuera de rango: suben los contadores, y el sistema sigue leyendo. Ahora detengo solo el firmware de la bomba: ese equipo pasa a reconectando y su línea se corta, pero el compresor y el motor siguen enviando datos sin enterarse. Lo reinicio, y la aplicación se reconecta sola, sin reiniciarla. Por último saturo la CPU: la gráfica sube casi al cien por ciento y la integración sigue funcionando. Estos seis fallos, con su salida de consola real, están documentados en el repositorio.</a:t>
+Ahora lo más importante: qué pasa cuando algo falla. Desde este panel provoco fallos reales. Fuerzo una anomalía y aparece el punto rojo. Mando un dato corrupto y un valor fuera de rango: suben los contadores, y el sistema sigue leyendo. Ahora apago solo la bomba: ese equipo pasa a reconectando y su línea se corta, pero el compresor y el motor siguen enviando datos sin enterarse. La vuelvo a encender, y la aplicación se reconecta sola, sin reiniciarla. Por último saturo la CPU: la gráfica sube casi al cien por ciento y la integración sigue funcionando. Estos seis fallos, con su salida de consola real, están documentados en el repositorio.</a:t>
             </a:r>
             <a:endParaRPr lang="en-US" dirty="0"/>
           </a:p>
@@ -1376,7 +1376,7 @@
             <a:r>
               <a:rPr lang="en-US" dirty="0"/>
               <a:t>[En pantalla: github.com/Facabore/practica-hsf-segundo-corte con el README renderizado]
-Este es el repositorio en GitHub. La estructura separa claramente la aplicación en hsf_app, el firmware simulado, las pruebas, los scripts de demo, los diagramas y la documentación. El README explica cómo instalar las dependencias y cómo correr el sistema completo, con dos terminales: una para el firmware y otra para la aplicación. Todo lo que voy a mostrar en este video se puede reproducir exactamente con estos comandos, en Windows o en Linux. Además, el sistema quedó publicado en la nube, con HTTPS, en integration-corte2.duckdns.org: cualquiera puede verlo funcionando en vivo, en modo solo lectura.</a:t>
+Este es el repositorio en GitHub. La estructura separa claramente la aplicación en hsf_app, el firmware simulado, las pruebas, los scripts de demo, los diagramas y la documentación. El README explica cómo instalar las dependencias y cómo correr el sistema completo, con dos terminales: una para el firmware y otra para la aplicación. Todo lo que voy a mostrar en este video se puede reproducir exactamente con estos comandos, en Windows o en Linux. Además, el sistema quedó publicado en la nube, con HTTPS, en integration-corte2.duckdns.org: cualquiera puede verlo funcionando en vivo.</a:t>
             </a:r>
             <a:endParaRPr lang="en-US" dirty="0"/>
           </a:p>
@@ -1820,8 +1820,8 @@
           <a:p>
             <a:r>
               <a:rPr lang="en-US" dirty="0"/>
-              <a:t>[En pantalla: terminal ejecutando "pytest tests/ -v" en vivo, 78 en verde; luego docs/Matriz_Pruebas.md]
-El proyecto tiene setenta y ocho pruebas automáticas con pytest, escritas con test primero, implementación después — es decir, TDD real. Las voy a correr ahora mismo [ejecutar pytest tests/ -v en pantalla]. Como se ve, las setenta y ocho pasan. La matriz de pruebas del documento técnico cruza cada requisito funcional con su prueba automática y, cuando corresponde, con una corrida manual real contra el sistema completo — no son pruebas teóricas, son pruebas que de verdad se ejecutaron.</a:t>
+              <a:t>[En pantalla: terminal ejecutando "pytest tests/ -v" en vivo, 85 en verde; luego docs/Matriz_Pruebas.md]
+El proyecto tiene ochenta y cinco pruebas automáticas con pytest, escritas con test primero, implementación después — es decir, TDD real. Las voy a correr ahora mismo [ejecutar pytest tests/ -v en pantalla]. Como se ve, las ochenta y cinco pasan. La matriz de pruebas del documento técnico cruza cada requisito funcional con su prueba automática y, cuando corresponde, con una corrida manual real contra el sistema completo — no son pruebas teóricas, son pruebas que de verdad se ejecutaron.</a:t>
             </a:r>
             <a:endParaRPr lang="en-US" dirty="0"/>
           </a:p>
@@ -8558,7 +8558,7 @@
                   <a:schemeClr val="tx1"/>
                 </a:solidFill>
               </a:rPr>
-              <a:t>TDD: 78 pruebas escritas antes que el código</a:t>
+              <a:t>TDD: 85 pruebas escritas antes que el código</a:t>
             </a:r>
             <a:endParaRPr lang="en-US" sz="1400" dirty="0"/>
           </a:p>
@@ -10025,7 +10025,7 @@
                 <a:ea typeface="Courier New" pitchFamily="34" charset="-122"/>
                 <a:cs typeface="Courier New" pitchFamily="34" charset="-120"/>
               </a:rPr>
-              <a:t>78 pruebas pytest</a:t>
+              <a:t>85 pruebas pytest</a:t>
             </a:r>
             <a:endParaRPr lang="en-US" sz="1300" dirty="0"/>
           </a:p>
@@ -10246,7 +10246,7 @@
                   <a:schemeClr val="accent4"/>
                 </a:solidFill>
               </a:rPr>
-              <a:t>78</a:t>
+              <a:t>85</a:t>
             </a:r>
             <a:endParaRPr lang="en-US" sz="4400" dirty="0"/>
           </a:p>
@@ -17640,7 +17640,7 @@
                   <a:schemeClr val="tx1"/>
                 </a:solidFill>
               </a:rPr>
-              <a:t>78 de 78 pruebas pytest en verde · detalle completo en docs/Matriz_Pruebas.md</a:t>
+              <a:t>85 de 85 pruebas pytest en verde · detalle completo en docs/Matriz_Pruebas.md</a:t>
             </a:r>
             <a:endParaRPr lang="en-US" sz="1400" dirty="0"/>
           </a:p>

</xml_diff>

<commit_message>
docs: update test count to 87
</commit_message>
<xml_diff>
--- a/docs/Diapositivas_Video_SegundoCorte.pptx
+++ b/docs/Diapositivas_Video_SegundoCorte.pptx
@@ -121,18 +121,18 @@
   <p:extLst>
     <p:ext uri="{521415D9-36F7-43E2-AB2F-B90AF26B5E84}">
       <p14:sectionLst xmlns:p14="http://schemas.microsoft.com/office/powerpoint/2010/main">
-        <p14:section name="Apertura" id="{b87cdde9-12ca-c175-ee9c-f57bf3cad8ea}">
+        <p14:section name="Apertura" id="{2be5a78c-e9bc-f48f-6fb7-25e3ce4d3597}">
           <p14:sldIdLst>
             <p14:sldId id="256"/>
           </p14:sldIdLst>
         </p14:section>
-        <p14:section name="Arquitectura" id="{a563c1c7-88cc-c8b4-794a-4cda50f3efcc}">
+        <p14:section name="Arquitectura" id="{ad1def62-c6ff-3d16-7ba5-511b349dd1f9}">
           <p14:sldIdLst>
             <p14:sldId id="257"/>
             <p14:sldId id="258"/>
           </p14:sldIdLst>
         </p14:section>
-        <p14:section name="Implementación" id="{344e306b-6346-568a-c052-95355b15eaff}">
+        <p14:section name="Implementación" id="{2fecbcd6-0c9d-ae9f-2b04-290828d20bc9}">
           <p14:sldIdLst>
             <p14:sldId id="259"/>
             <p14:sldId id="260"/>
@@ -141,20 +141,20 @@
             <p14:sldId id="263"/>
           </p14:sldIdLst>
         </p14:section>
-        <p14:section name="Validación" id="{20da7408-9bb4-6ea5-b6f8-efd86be1bd8d}">
+        <p14:section name="Validación" id="{3c86d1a1-eb0e-7722-3cca-fc9b4ee396f5}">
           <p14:sldIdLst>
             <p14:sldId id="264"/>
             <p14:sldId id="265"/>
             <p14:sldId id="266"/>
           </p14:sldIdLst>
         </p14:section>
-        <p14:section name="Preguntas" id="{fb5fb8f7-727d-c674-07d9-738f45259f0c}">
+        <p14:section name="Preguntas" id="{da8326fc-a82e-2c7f-147a-c18ecbef9b22}">
           <p14:sldIdLst>
             <p14:sldId id="267"/>
             <p14:sldId id="268"/>
           </p14:sldIdLst>
         </p14:section>
-        <p14:section name="Cierre" id="{459247b3-ba87-39cd-bc4c-73513748137c}">
+        <p14:section name="Cierre" id="{009c9a7b-7deb-5cc5-6620-b5e571eca4ca}">
           <p14:sldIdLst>
             <p14:sldId id="269"/>
             <p14:sldId id="270"/>
@@ -1820,7 +1820,7 @@
           <a:p>
             <a:r>
               <a:rPr lang="en-US" dirty="0"/>
-              <a:t>[En pantalla: terminal ejecutando "pytest tests/ -v" en vivo, 85 en verde; luego docs/Matriz_Pruebas.md]
+              <a:t>[En pantalla: terminal ejecutando "pytest tests/ -v" en vivo, 87 en verde; luego docs/Matriz_Pruebas.md]
 El proyecto tiene ochenta y cinco pruebas automáticas con pytest, escritas con test primero, implementación después — es decir, TDD real. Las voy a correr ahora mismo [ejecutar pytest tests/ -v en pantalla]. Como se ve, las ochenta y cinco pasan. La matriz de pruebas del documento técnico cruza cada requisito funcional con su prueba automática y, cuando corresponde, con una corrida manual real contra el sistema completo — no son pruebas teóricas, son pruebas que de verdad se ejecutaron.</a:t>
             </a:r>
             <a:endParaRPr lang="en-US" dirty="0"/>
@@ -8558,7 +8558,7 @@
                   <a:schemeClr val="tx1"/>
                 </a:solidFill>
               </a:rPr>
-              <a:t>TDD: 85 pruebas escritas antes que el código</a:t>
+              <a:t>TDD: 87 pruebas escritas antes que el código</a:t>
             </a:r>
             <a:endParaRPr lang="en-US" sz="1400" dirty="0"/>
           </a:p>
@@ -10025,7 +10025,7 @@
                 <a:ea typeface="Courier New" pitchFamily="34" charset="-122"/>
                 <a:cs typeface="Courier New" pitchFamily="34" charset="-120"/>
               </a:rPr>
-              <a:t>85 pruebas pytest</a:t>
+              <a:t>87 pruebas pytest</a:t>
             </a:r>
             <a:endParaRPr lang="en-US" sz="1300" dirty="0"/>
           </a:p>
@@ -10246,7 +10246,7 @@
                   <a:schemeClr val="accent4"/>
                 </a:solidFill>
               </a:rPr>
-              <a:t>85</a:t>
+              <a:t>87</a:t>
             </a:r>
             <a:endParaRPr lang="en-US" sz="4400" dirty="0"/>
           </a:p>
@@ -17640,7 +17640,7 @@
                   <a:schemeClr val="tx1"/>
                 </a:solidFill>
               </a:rPr>
-              <a:t>85 de 85 pruebas pytest en verde · detalle completo en docs/Matriz_Pruebas.md</a:t>
+              <a:t>87 de 87 pruebas pytest en verde · detalle completo en docs/Matriz_Pruebas.md</a:t>
             </a:r>
             <a:endParaRPr lang="en-US" sz="1400" dirty="0"/>
           </a:p>

</xml_diff>

<commit_message>
docs: fix spelled-out test count and fault-demo cue in the video script
</commit_message>
<xml_diff>
--- a/docs/Diapositivas_Video_SegundoCorte.pptx
+++ b/docs/Diapositivas_Video_SegundoCorte.pptx
@@ -121,18 +121,18 @@
   <p:extLst>
     <p:ext uri="{521415D9-36F7-43E2-AB2F-B90AF26B5E84}">
       <p14:sectionLst xmlns:p14="http://schemas.microsoft.com/office/powerpoint/2010/main">
-        <p14:section name="Apertura" id="{2be5a78c-e9bc-f48f-6fb7-25e3ce4d3597}">
+        <p14:section name="Apertura" id="{86ca3b27-e988-094f-e72e-d697ca90b2c0}">
           <p14:sldIdLst>
             <p14:sldId id="256"/>
           </p14:sldIdLst>
         </p14:section>
-        <p14:section name="Arquitectura" id="{ad1def62-c6ff-3d16-7ba5-511b349dd1f9}">
+        <p14:section name="Arquitectura" id="{22d012e2-80c2-3e1d-0ed1-dda7880957be}">
           <p14:sldIdLst>
             <p14:sldId id="257"/>
             <p14:sldId id="258"/>
           </p14:sldIdLst>
         </p14:section>
-        <p14:section name="Implementación" id="{2fecbcd6-0c9d-ae9f-2b04-290828d20bc9}">
+        <p14:section name="Implementación" id="{6ff950a9-e9c7-390e-f951-d03447eaf7d3}">
           <p14:sldIdLst>
             <p14:sldId id="259"/>
             <p14:sldId id="260"/>
@@ -141,20 +141,20 @@
             <p14:sldId id="263"/>
           </p14:sldIdLst>
         </p14:section>
-        <p14:section name="Validación" id="{3c86d1a1-eb0e-7722-3cca-fc9b4ee396f5}">
+        <p14:section name="Validación" id="{466b6955-8b3d-db52-bfd4-be9c75160190}">
           <p14:sldIdLst>
             <p14:sldId id="264"/>
             <p14:sldId id="265"/>
             <p14:sldId id="266"/>
           </p14:sldIdLst>
         </p14:section>
-        <p14:section name="Preguntas" id="{da8326fc-a82e-2c7f-147a-c18ecbef9b22}">
+        <p14:section name="Preguntas" id="{cf556caf-2d79-3ca2-83c2-98df91e2e1b1}">
           <p14:sldIdLst>
             <p14:sldId id="267"/>
             <p14:sldId id="268"/>
           </p14:sldIdLst>
         </p14:section>
-        <p14:section name="Cierre" id="{009c9a7b-7deb-5cc5-6620-b5e571eca4ca}">
+        <p14:section name="Cierre" id="{94bd0a19-d4ad-5971-e676-cbaaee0c9364}">
           <p14:sldIdLst>
             <p14:sldId id="269"/>
             <p14:sldId id="270"/>
@@ -653,7 +653,7 @@
           <a:p>
             <a:r>
               <a:rPr lang="en-US" dirty="0"/>
-              <a:t>[En pantalla: logs/sistema.log y el fallo 6 de docs/Fallos_Controlados.md]
+              <a:t>[En pantalla: dashboard, pestaña SIM-002: Forzar una anomalía, Enviar dato corrupto, Valor fuera de rango, Apagar el equipo; volver a General; Encender el equipo; Saturar la CPU 5 s]
 Ahora lo más importante: qué pasa cuando algo falla. Desde este panel provoco fallos reales. Fuerzo una anomalía y aparece el punto rojo. Mando un dato corrupto y un valor fuera de rango: suben los contadores, y el sistema sigue leyendo. Ahora apago solo la bomba: ese equipo pasa a reconectando y su línea se corta, pero el compresor y el motor siguen enviando datos sin enterarse. La vuelvo a encender, y la aplicación se reconecta sola, sin reiniciarla. Por último saturo la CPU: la gráfica sube casi al cien por ciento y la integración sigue funcionando. Estos seis fallos, con su salida de consola real, están documentados en el repositorio.</a:t>
             </a:r>
             <a:endParaRPr lang="en-US" dirty="0"/>
@@ -1821,7 +1821,7 @@
             <a:r>
               <a:rPr lang="en-US" dirty="0"/>
               <a:t>[En pantalla: terminal ejecutando "pytest tests/ -v" en vivo, 87 en verde; luego docs/Matriz_Pruebas.md]
-El proyecto tiene ochenta y cinco pruebas automáticas con pytest, escritas con test primero, implementación después — es decir, TDD real. Las voy a correr ahora mismo [ejecutar pytest tests/ -v en pantalla]. Como se ve, las ochenta y cinco pasan. La matriz de pruebas del documento técnico cruza cada requisito funcional con su prueba automática y, cuando corresponde, con una corrida manual real contra el sistema completo — no son pruebas teóricas, son pruebas que de verdad se ejecutaron.</a:t>
+El proyecto tiene ochenta y siete pruebas automáticas con pytest, escritas con test primero, implementación después — es decir, TDD real. Las voy a correr ahora mismo [ejecutar pytest tests/ -v en pantalla]. Como se ve, las ochenta y siete pasan. La matriz de pruebas del documento técnico cruza cada requisito funcional con su prueba automática y, cuando corresponde, con una corrida manual real contra el sistema completo — no son pruebas teóricas, son pruebas que de verdad se ejecutaron.</a:t>
             </a:r>
             <a:endParaRPr lang="en-US" dirty="0"/>
           </a:p>

</xml_diff>

<commit_message>
docs: document the report download and update test count to 90
</commit_message>
<xml_diff>
--- a/docs/Diapositivas_Video_SegundoCorte.pptx
+++ b/docs/Diapositivas_Video_SegundoCorte.pptx
@@ -121,18 +121,18 @@
   <p:extLst>
     <p:ext uri="{521415D9-36F7-43E2-AB2F-B90AF26B5E84}">
       <p14:sectionLst xmlns:p14="http://schemas.microsoft.com/office/powerpoint/2010/main">
-        <p14:section name="Apertura" id="{86ca3b27-e988-094f-e72e-d697ca90b2c0}">
+        <p14:section name="Apertura" id="{97d2a039-efed-410a-0dd7-c2971cf2d37c}">
           <p14:sldIdLst>
             <p14:sldId id="256"/>
           </p14:sldIdLst>
         </p14:section>
-        <p14:section name="Arquitectura" id="{22d012e2-80c2-3e1d-0ed1-dda7880957be}">
+        <p14:section name="Arquitectura" id="{5ddc1951-6a26-ee62-6756-b7a4d6882578}">
           <p14:sldIdLst>
             <p14:sldId id="257"/>
             <p14:sldId id="258"/>
           </p14:sldIdLst>
         </p14:section>
-        <p14:section name="Implementación" id="{6ff950a9-e9c7-390e-f951-d03447eaf7d3}">
+        <p14:section name="Implementación" id="{e83d367b-4cd7-81bb-2a99-d0f0a28b0587}">
           <p14:sldIdLst>
             <p14:sldId id="259"/>
             <p14:sldId id="260"/>
@@ -141,20 +141,20 @@
             <p14:sldId id="263"/>
           </p14:sldIdLst>
         </p14:section>
-        <p14:section name="Validación" id="{466b6955-8b3d-db52-bfd4-be9c75160190}">
+        <p14:section name="Validación" id="{d4de7dfc-5cd7-b560-4dfb-7f1661e7d1b9}">
           <p14:sldIdLst>
             <p14:sldId id="264"/>
             <p14:sldId id="265"/>
             <p14:sldId id="266"/>
           </p14:sldIdLst>
         </p14:section>
-        <p14:section name="Preguntas" id="{cf556caf-2d79-3ca2-83c2-98df91e2e1b1}">
+        <p14:section name="Preguntas" id="{ebaccb2d-dd8a-f119-790d-ba2622a4a8b8}">
           <p14:sldIdLst>
             <p14:sldId id="267"/>
             <p14:sldId id="268"/>
           </p14:sldIdLst>
         </p14:section>
-        <p14:section name="Cierre" id="{94bd0a19-d4ad-5971-e676-cbaaee0c9364}">
+        <p14:section name="Cierre" id="{c9541294-b7ca-74f6-7b93-d111dcd1f093}">
           <p14:sldIdLst>
             <p14:sldId id="269"/>
             <p14:sldId id="270"/>
@@ -1732,7 +1732,7 @@
             <a:r>
               <a:rPr lang="en-US" dirty="0"/>
               <a:t>[En pantalla: data/lecturas.csv y data/reporte_ejecucion.json reales]
-Esta es una corrida real de veinte lecturas. En el CSV se ve cada lectura con su marca de tiempo y su estado: la mayoría normales, y dos marcadas como anómalas, exactamente las que el firmware inyectó a propósito. Y este es el reporte de ejecución en JSON: trae las métricas agregadas — lecturas válidas, anómalas, errores — y además un snapshot real de los recursos del sistema operativo en el momento del cierre: uso de CPU, memoria, disco y el PID del proceso. Ningún dato de este reporte está inventado, es la salida real de haber corrido el sistema.</a:t>
+Esta es una corrida real de veinte lecturas. En el CSV se ve cada lectura con su marca de tiempo y su estado: la mayoría normales, y dos marcadas como anómalas, exactamente las que el firmware inyectó a propósito. Y este es el reporte de ejecución en JSON: trae las métricas agregadas — lecturas válidas, anómalas, errores — y además un snapshot real de los recursos del sistema operativo en el momento del cierre: uso de CPU, memoria, disco y el PID del proceso. Ningún dato de este reporte está inventado, es la salida real de haber corrido el sistema. Este reporte se escribe al cerrar la ejecución, pero no hace falta esperar: en el panel, el botón Descargar reporte lo genera en el momento, con los datos de los tres equipos.</a:t>
             </a:r>
             <a:endParaRPr lang="en-US" dirty="0"/>
           </a:p>
@@ -1820,8 +1820,8 @@
           <a:p>
             <a:r>
               <a:rPr lang="en-US" dirty="0"/>
-              <a:t>[En pantalla: terminal ejecutando "pytest tests/ -v" en vivo, 87 en verde; luego docs/Matriz_Pruebas.md]
-El proyecto tiene ochenta y siete pruebas automáticas con pytest, escritas con test primero, implementación después — es decir, TDD real. Las voy a correr ahora mismo [ejecutar pytest tests/ -v en pantalla]. Como se ve, las ochenta y siete pasan. La matriz de pruebas del documento técnico cruza cada requisito funcional con su prueba automática y, cuando corresponde, con una corrida manual real contra el sistema completo — no son pruebas teóricas, son pruebas que de verdad se ejecutaron.</a:t>
+              <a:t>[En pantalla: terminal ejecutando "pytest tests/ -v" en vivo, 90 en verde; luego docs/Matriz_Pruebas.md]
+El proyecto tiene noventa pruebas automáticas con pytest, escritas con test primero, implementación después — es decir, TDD real. Las voy a correr ahora mismo [ejecutar pytest tests/ -v en pantalla]. Como se ve, las noventa pasan. La matriz de pruebas del documento técnico cruza cada requisito funcional con su prueba automática y, cuando corresponde, con una corrida manual real contra el sistema completo — no son pruebas teóricas, son pruebas que de verdad se ejecutaron.</a:t>
             </a:r>
             <a:endParaRPr lang="en-US" dirty="0"/>
           </a:p>
@@ -8558,7 +8558,7 @@
                   <a:schemeClr val="tx1"/>
                 </a:solidFill>
               </a:rPr>
-              <a:t>TDD: 87 pruebas escritas antes que el código</a:t>
+              <a:t>TDD: 90 pruebas escritas antes que el código</a:t>
             </a:r>
             <a:endParaRPr lang="en-US" sz="1400" dirty="0"/>
           </a:p>
@@ -10025,7 +10025,7 @@
                 <a:ea typeface="Courier New" pitchFamily="34" charset="-122"/>
                 <a:cs typeface="Courier New" pitchFamily="34" charset="-120"/>
               </a:rPr>
-              <a:t>87 pruebas pytest</a:t>
+              <a:t>90 pruebas pytest</a:t>
             </a:r>
             <a:endParaRPr lang="en-US" sz="1300" dirty="0"/>
           </a:p>
@@ -10246,7 +10246,7 @@
                   <a:schemeClr val="accent4"/>
                 </a:solidFill>
               </a:rPr>
-              <a:t>87</a:t>
+              <a:t>90</a:t>
             </a:r>
             <a:endParaRPr lang="en-US" sz="4400" dirty="0"/>
           </a:p>
@@ -17640,7 +17640,7 @@
                   <a:schemeClr val="tx1"/>
                 </a:solidFill>
               </a:rPr>
-              <a:t>87 de 87 pruebas pytest en verde · detalle completo en docs/Matriz_Pruebas.md</a:t>
+              <a:t>90 de 90 pruebas pytest en verde · detalle completo en docs/Matriz_Pruebas.md</a:t>
             </a:r>
             <a:endParaRPr lang="en-US" sz="1400" dirty="0"/>
           </a:p>

</xml_diff>

<commit_message>
docs: document CSV report download and update test count to 95
</commit_message>
<xml_diff>
--- a/docs/Diapositivas_Video_SegundoCorte.pptx
+++ b/docs/Diapositivas_Video_SegundoCorte.pptx
@@ -121,18 +121,18 @@
   <p:extLst>
     <p:ext uri="{521415D9-36F7-43E2-AB2F-B90AF26B5E84}">
       <p14:sectionLst xmlns:p14="http://schemas.microsoft.com/office/powerpoint/2010/main">
-        <p14:section name="Apertura" id="{97d2a039-efed-410a-0dd7-c2971cf2d37c}">
+        <p14:section name="Apertura" id="{b66a639a-6323-17c9-56c5-c17af5a17547}">
           <p14:sldIdLst>
             <p14:sldId id="256"/>
           </p14:sldIdLst>
         </p14:section>
-        <p14:section name="Arquitectura" id="{5ddc1951-6a26-ee62-6756-b7a4d6882578}">
+        <p14:section name="Arquitectura" id="{3a8f8eb1-969d-da13-1a12-02a69211ec52}">
           <p14:sldIdLst>
             <p14:sldId id="257"/>
             <p14:sldId id="258"/>
           </p14:sldIdLst>
         </p14:section>
-        <p14:section name="Implementación" id="{e83d367b-4cd7-81bb-2a99-d0f0a28b0587}">
+        <p14:section name="Implementación" id="{f0918d1c-b6f6-6f9f-d69c-5c5485618372}">
           <p14:sldIdLst>
             <p14:sldId id="259"/>
             <p14:sldId id="260"/>
@@ -141,20 +141,20 @@
             <p14:sldId id="263"/>
           </p14:sldIdLst>
         </p14:section>
-        <p14:section name="Validación" id="{d4de7dfc-5cd7-b560-4dfb-7f1661e7d1b9}">
+        <p14:section name="Validación" id="{c29ee368-2095-e481-1ddc-8b06a8e649c4}">
           <p14:sldIdLst>
             <p14:sldId id="264"/>
             <p14:sldId id="265"/>
             <p14:sldId id="266"/>
           </p14:sldIdLst>
         </p14:section>
-        <p14:section name="Preguntas" id="{ebaccb2d-dd8a-f119-790d-ba2622a4a8b8}">
+        <p14:section name="Preguntas" id="{9b379b56-b654-2149-296d-dfb94d9d595d}">
           <p14:sldIdLst>
             <p14:sldId id="267"/>
             <p14:sldId id="268"/>
           </p14:sldIdLst>
         </p14:section>
-        <p14:section name="Cierre" id="{c9541294-b7ca-74f6-7b93-d111dcd1f093}">
+        <p14:section name="Cierre" id="{cba51563-3f48-fcf7-83cb-78244818cc93}">
           <p14:sldIdLst>
             <p14:sldId id="269"/>
             <p14:sldId id="270"/>
@@ -1732,7 +1732,7 @@
             <a:r>
               <a:rPr lang="en-US" dirty="0"/>
               <a:t>[En pantalla: data/lecturas.csv y data/reporte_ejecucion.json reales]
-Esta es una corrida real de veinte lecturas. En el CSV se ve cada lectura con su marca de tiempo y su estado: la mayoría normales, y dos marcadas como anómalas, exactamente las que el firmware inyectó a propósito. Y este es el reporte de ejecución en JSON: trae las métricas agregadas — lecturas válidas, anómalas, errores — y además un snapshot real de los recursos del sistema operativo en el momento del cierre: uso de CPU, memoria, disco y el PID del proceso. Ningún dato de este reporte está inventado, es la salida real de haber corrido el sistema. Este reporte se escribe al cerrar la ejecución, pero no hace falta esperar: en el panel, el botón Descargar reporte lo genera en el momento, con los datos de los tres equipos.</a:t>
+Esta es una corrida real de veinte lecturas. En el CSV se ve cada lectura con su marca de tiempo y su estado: la mayoría normales, y dos marcadas como anómalas, exactamente las que el firmware inyectó a propósito. Y este es el reporte de ejecución en JSON: trae las métricas agregadas — lecturas válidas, anómalas, errores — y además un snapshot real de los recursos del sistema operativo en el momento del cierre: uso de CPU, memoria, disco y el PID del proceso. Ningún dato de este reporte está inventado, es la salida real de haber corrido el sistema. Este reporte se escribe al cerrar la ejecución, pero no hace falta esperar: en el panel, el botón Descargar reporte lo genera en el momento, en JSON o en CSV para abrirlo en Excel, con los datos de los tres equipos.</a:t>
             </a:r>
             <a:endParaRPr lang="en-US" dirty="0"/>
           </a:p>
@@ -1820,8 +1820,8 @@
           <a:p>
             <a:r>
               <a:rPr lang="en-US" dirty="0"/>
-              <a:t>[En pantalla: terminal ejecutando "pytest tests/ -v" en vivo, 90 en verde; luego docs/Matriz_Pruebas.md]
-El proyecto tiene noventa pruebas automáticas con pytest, escritas con test primero, implementación después — es decir, TDD real. Las voy a correr ahora mismo [ejecutar pytest tests/ -v en pantalla]. Como se ve, las noventa pasan. La matriz de pruebas del documento técnico cruza cada requisito funcional con su prueba automática y, cuando corresponde, con una corrida manual real contra el sistema completo — no son pruebas teóricas, son pruebas que de verdad se ejecutaron.</a:t>
+              <a:t>[En pantalla: terminal ejecutando "pytest tests/ -v" en vivo, 95 en verde; luego docs/Matriz_Pruebas.md]
+El proyecto tiene noventa y cinco pruebas automáticas con pytest, escritas con test primero, implementación después — es decir, TDD real. Las voy a correr ahora mismo [ejecutar pytest tests/ -v en pantalla]. Como se ve, las noventa y cinco pasan. La matriz de pruebas del documento técnico cruza cada requisito funcional con su prueba automática y, cuando corresponde, con una corrida manual real contra el sistema completo — no son pruebas teóricas, son pruebas que de verdad se ejecutaron.</a:t>
             </a:r>
             <a:endParaRPr lang="en-US" dirty="0"/>
           </a:p>
@@ -8558,7 +8558,7 @@
                   <a:schemeClr val="tx1"/>
                 </a:solidFill>
               </a:rPr>
-              <a:t>TDD: 90 pruebas escritas antes que el código</a:t>
+              <a:t>TDD: 95 pruebas escritas antes que el código</a:t>
             </a:r>
             <a:endParaRPr lang="en-US" sz="1400" dirty="0"/>
           </a:p>
@@ -10025,7 +10025,7 @@
                 <a:ea typeface="Courier New" pitchFamily="34" charset="-122"/>
                 <a:cs typeface="Courier New" pitchFamily="34" charset="-120"/>
               </a:rPr>
-              <a:t>90 pruebas pytest</a:t>
+              <a:t>95 pruebas pytest</a:t>
             </a:r>
             <a:endParaRPr lang="en-US" sz="1300" dirty="0"/>
           </a:p>
@@ -10246,7 +10246,7 @@
                   <a:schemeClr val="accent4"/>
                 </a:solidFill>
               </a:rPr>
-              <a:t>90</a:t>
+              <a:t>95</a:t>
             </a:r>
             <a:endParaRPr lang="en-US" sz="4400" dirty="0"/>
           </a:p>
@@ -17640,7 +17640,7 @@
                   <a:schemeClr val="tx1"/>
                 </a:solidFill>
               </a:rPr>
-              <a:t>90 de 90 pruebas pytest en verde · detalle completo en docs/Matriz_Pruebas.md</a:t>
+              <a:t>95 de 95 pruebas pytest en verde · detalle completo en docs/Matriz_Pruebas.md</a:t>
             </a:r>
             <a:endParaRPr lang="en-US" sz="1400" dirty="0"/>
           </a:p>

</xml_diff>